<commit_message>
Site et pitch anglais passés en sip lab avec le nouveau logo
Co-Authored-By: Claude Opus 5.5 <noreply@anthropic.com>
Claude-Session: https://claude.ai/code/session_01GhVoXRgaJJbfXgbund27Nd
</commit_message>
<xml_diff>
--- a/pitch/siplab-pitch-EN.pptx
+++ b/pitch/siplab-pitch-EN.pptx
@@ -120,44 +120,44 @@
   <p:extLst>
     <p:ext uri="{521415D9-36F7-43E2-AB2F-B90AF26B5E84}">
       <p14:sectionLst xmlns:p14="http://schemas.microsoft.com/office/powerpoint/2010/main">
-        <p14:section name="Opening" id="{29bd0c19-8925-73eb-7b32-4a4d92664bf7}">
+        <p14:section name="Opening" id="{d6dca191-bcea-e8d5-e2aa-e477a1ebe178}">
           <p14:sldIdLst>
             <p14:sldId id="256"/>
           </p14:sldIdLst>
         </p14:section>
-        <p14:section name="Problem &amp; solution" id="{59a760c7-bcf6-c04b-7907-5e80b2b2d1be}">
+        <p14:section name="Problem &amp; solution" id="{98c1f50b-279e-5a7e-bd5d-ebf3765d183e}">
           <p14:sldIdLst>
             <p14:sldId id="257"/>
             <p14:sldId id="258"/>
             <p14:sldId id="259"/>
           </p14:sldIdLst>
         </p14:section>
-        <p14:section name="Market" id="{e50d0a80-cc1e-4a54-a436-3a1e9f95cc8c}">
+        <p14:section name="Market" id="{da4da198-a4ae-a42e-2d16-a6f2330352bb}">
           <p14:sldIdLst>
             <p14:sldId id="260"/>
             <p14:sldId id="261"/>
             <p14:sldId id="262"/>
           </p14:sldIdLst>
         </p14:section>
-        <p14:section name="Model &amp; growth" id="{2643593e-62af-c0b4-cd28-ab78de777cd9}">
+        <p14:section name="Model &amp; growth" id="{4df42e5c-c7c6-b180-cbf6-0c4287562810}">
           <p14:sldIdLst>
             <p14:sldId id="263"/>
             <p14:sldId id="264"/>
             <p14:sldId id="265"/>
           </p14:sldIdLst>
         </p14:section>
-        <p14:section name="Team &amp; funding" id="{381ed2d7-b138-3f56-f25f-ede6e6bd4152}">
+        <p14:section name="Team &amp; funding" id="{da50fecc-9ffd-588e-5987-98491661f24f}">
           <p14:sldIdLst>
             <p14:sldId id="266"/>
             <p14:sldId id="267"/>
           </p14:sldIdLst>
         </p14:section>
-        <p14:section name="Conclusion" id="{c7addcda-f417-f52e-06db-f2ee666ba696}">
+        <p14:section name="Conclusion" id="{bef48d92-248b-603f-fe64-cd3aac725c4f}">
           <p14:sldIdLst>
             <p14:sldId id="268"/>
           </p14:sldIdLst>
         </p14:section>
-        <p14:section name="Appendix" id="{821d0994-c354-9cc6-3fec-5792eb95aba6}">
+        <p14:section name="Appendix" id="{f75eda93-c307-b5ec-631e-57c87081f478}">
           <p14:sldIdLst>
             <p14:sldId id="269"/>
           </p14:sldIdLst>
@@ -2635,250 +2635,9 @@
           <a:chExt cx="0" cy="0"/>
         </a:xfrm>
       </p:grpSpPr>
-      <p:sp>
-        <p:nvSpPr>
-          <p:cNvPr id="2" name="Text 0"/>
-          <p:cNvSpPr txBox="1"/>
-          <p:nvPr/>
-        </p:nvSpPr>
-        <p:spPr>
-          <a:xfrm>
-            <a:off x="457200" y="822960"/>
-            <a:ext cx="4023360" cy="1005840"/>
-          </a:xfrm>
-          <a:prstGeom prst="rect">
-            <a:avLst/>
-          </a:prstGeom>
-          <a:noFill/>
-          <a:ln/>
-        </p:spPr>
-        <p:txBody>
-          <a:bodyPr wrap="square" lIns="0" tIns="0" rIns="0" bIns="0" rtlCol="0" anchor="ctr"/>
-          <a:lstStyle/>
-          <a:p>
-            <a:pPr indent="0" marL="0">
-              <a:buNone/>
-            </a:pPr>
-            <a:r>
-              <a:rPr lang="en-US" sz="6000" b="1" spc="-100" kern="0" dirty="0">
-                <a:solidFill>
-                  <a:schemeClr val="bg2"/>
-                </a:solidFill>
-              </a:rPr>
-              <a:t>sip </a:t>
-            </a:r>
-            <a:pPr indent="0" marL="0">
-              <a:buNone/>
-            </a:pPr>
-            <a:r>
-              <a:rPr lang="en-US" sz="6000" b="1" i="1" spc="-100" kern="0" dirty="0">
-                <a:solidFill>
-                  <a:schemeClr val="bg2"/>
-                </a:solidFill>
-                <a:latin typeface="Cambria" pitchFamily="34" charset="0"/>
-                <a:ea typeface="Cambria" pitchFamily="34" charset="-122"/>
-                <a:cs typeface="Cambria" pitchFamily="34" charset="-120"/>
-              </a:rPr>
-              <a:t>lab</a:t>
-            </a:r>
-            <a:endParaRPr lang="en-US" sz="6000" dirty="0"/>
-          </a:p>
-        </p:txBody>
-      </p:sp>
-      <p:sp>
-        <p:nvSpPr>
-          <p:cNvPr id="3" name="bead0"/>
-          <p:cNvSpPr/>
-          <p:nvPr/>
-        </p:nvSpPr>
-        <p:spPr>
-          <a:xfrm>
-            <a:off x="502920" y="1920240"/>
-            <a:ext cx="164592" cy="164592"/>
-          </a:xfrm>
-          <a:prstGeom prst="ellipse">
-            <a:avLst/>
-          </a:prstGeom>
-          <a:solidFill>
-            <a:schemeClr val="accent3"/>
-          </a:solidFill>
-          <a:ln/>
-        </p:spPr>
-      </p:sp>
-      <p:sp>
-        <p:nvSpPr>
-          <p:cNvPr id="4" name="bead1"/>
-          <p:cNvSpPr/>
-          <p:nvPr/>
-        </p:nvSpPr>
-        <p:spPr>
-          <a:xfrm>
-            <a:off x="758952" y="1920240"/>
-            <a:ext cx="164592" cy="164592"/>
-          </a:xfrm>
-          <a:prstGeom prst="ellipse">
-            <a:avLst/>
-          </a:prstGeom>
-          <a:solidFill>
-            <a:schemeClr val="accent4"/>
-          </a:solidFill>
-          <a:ln/>
-        </p:spPr>
-      </p:sp>
-      <p:sp>
-        <p:nvSpPr>
-          <p:cNvPr id="5" name="bead2"/>
-          <p:cNvSpPr/>
-          <p:nvPr/>
-        </p:nvSpPr>
-        <p:spPr>
-          <a:xfrm>
-            <a:off x="1014984" y="1920240"/>
-            <a:ext cx="164592" cy="164592"/>
-          </a:xfrm>
-          <a:prstGeom prst="ellipse">
-            <a:avLst/>
-          </a:prstGeom>
-          <a:solidFill>
-            <a:schemeClr val="accent1"/>
-          </a:solidFill>
-          <a:ln/>
-        </p:spPr>
-      </p:sp>
-      <p:sp>
-        <p:nvSpPr>
-          <p:cNvPr id="6" name="bead3"/>
-          <p:cNvSpPr/>
-          <p:nvPr/>
-        </p:nvSpPr>
-        <p:spPr>
-          <a:xfrm>
-            <a:off x="1271016" y="1920240"/>
-            <a:ext cx="164592" cy="164592"/>
-          </a:xfrm>
-          <a:prstGeom prst="ellipse">
-            <a:avLst/>
-          </a:prstGeom>
-          <a:solidFill>
-            <a:schemeClr val="accent2"/>
-          </a:solidFill>
-          <a:ln/>
-        </p:spPr>
-      </p:sp>
-      <p:sp>
-        <p:nvSpPr>
-          <p:cNvPr id="7" name="Text 5"/>
-          <p:cNvSpPr txBox="1"/>
-          <p:nvPr/>
-        </p:nvSpPr>
-        <p:spPr>
-          <a:xfrm>
-            <a:off x="457200" y="2240280"/>
-            <a:ext cx="4023360" cy="548640"/>
-          </a:xfrm>
-          <a:prstGeom prst="rect">
-            <a:avLst/>
-          </a:prstGeom>
-          <a:noFill/>
-          <a:ln/>
-        </p:spPr>
-        <p:txBody>
-          <a:bodyPr wrap="square" lIns="0" tIns="0" rIns="0" bIns="0" rtlCol="0" anchor="ctr"/>
-          <a:lstStyle/>
-          <a:p>
-            <a:pPr indent="0" marL="0">
-              <a:buNone/>
-            </a:pPr>
-            <a:r>
-              <a:rPr lang="en-US" sz="2600" i="1" dirty="0">
-                <a:solidFill>
-                  <a:schemeClr val="bg2"/>
-                </a:solidFill>
-                <a:latin typeface="Cambria" pitchFamily="34" charset="0"/>
-                <a:ea typeface="Cambria" pitchFamily="34" charset="-122"/>
-                <a:cs typeface="Cambria" pitchFamily="34" charset="-120"/>
-              </a:rPr>
-              <a:t>one sip for every age</a:t>
-            </a:r>
-            <a:endParaRPr lang="en-US" sz="2600" dirty="0"/>
-          </a:p>
-        </p:txBody>
-      </p:sp>
-      <p:sp>
-        <p:nvSpPr>
-          <p:cNvPr id="8" name="Text 6"/>
-          <p:cNvSpPr txBox="1"/>
-          <p:nvPr/>
-        </p:nvSpPr>
-        <p:spPr>
-          <a:xfrm>
-            <a:off x="457200" y="2834640"/>
-            <a:ext cx="3840480" cy="594360"/>
-          </a:xfrm>
-          <a:prstGeom prst="rect">
-            <a:avLst/>
-          </a:prstGeom>
-          <a:noFill/>
-          <a:ln/>
-        </p:spPr>
-        <p:txBody>
-          <a:bodyPr wrap="square" lIns="0" tIns="0" rIns="0" bIns="0" rtlCol="0" anchor="ctr"/>
-          <a:lstStyle/>
-          <a:p>
-            <a:pPr indent="0" marL="0">
-              <a:buNone/>
-            </a:pPr>
-            <a:r>
-              <a:rPr lang="en-US" sz="1400" dirty="0">
-                <a:solidFill>
-                  <a:srgbClr val="D6CFC6"/>
-                </a:solidFill>
-              </a:rPr>
-              <a:t>The active straw: food supplements you drink, in 4 ranges, for ages 4 to 104.</a:t>
-            </a:r>
-            <a:endParaRPr lang="en-US" sz="1400" dirty="0"/>
-          </a:p>
-        </p:txBody>
-      </p:sp>
-      <p:sp>
-        <p:nvSpPr>
-          <p:cNvPr id="9" name="Text 7"/>
-          <p:cNvSpPr txBox="1"/>
-          <p:nvPr/>
-        </p:nvSpPr>
-        <p:spPr>
-          <a:xfrm>
-            <a:off x="457200" y="4343400"/>
-            <a:ext cx="4023360" cy="274320"/>
-          </a:xfrm>
-          <a:prstGeom prst="rect">
-            <a:avLst/>
-          </a:prstGeom>
-          <a:noFill/>
-          <a:ln/>
-        </p:spPr>
-        <p:txBody>
-          <a:bodyPr wrap="square" lIns="0" tIns="0" rIns="0" bIns="0" rtlCol="0" anchor="ctr"/>
-          <a:lstStyle/>
-          <a:p>
-            <a:pPr indent="0" marL="0">
-              <a:buNone/>
-            </a:pPr>
-            <a:r>
-              <a:rPr lang="en-US" sz="1100" dirty="0">
-                <a:solidFill>
-                  <a:srgbClr val="A99F96"/>
-                </a:solidFill>
-              </a:rPr>
-              <a:t>Nisrine Margoum · founder · investor pitch</a:t>
-            </a:r>
-            <a:endParaRPr lang="en-US" sz="1100" dirty="0"/>
-          </a:p>
-        </p:txBody>
-      </p:sp>
       <p:pic>
         <p:nvPicPr>
-          <p:cNvPr id="10" name="cover-mini" descr="cover-mini">    </p:cNvPr>
+          <p:cNvPr id="2" name="logo" descr="sip lab logo">    </p:cNvPr>
           <p:cNvPicPr>
             <a:picLocks noChangeAspect="1"/>
           </p:cNvPicPr>
@@ -2892,8 +2651,8 @@
         </p:blipFill>
         <p:spPr>
           <a:xfrm>
-            <a:off x="4572000" y="457200"/>
-            <a:ext cx="2011680" cy="2057400"/>
+            <a:off x="320040" y="685800"/>
+            <a:ext cx="3383280" cy="1383283"/>
           </a:xfrm>
           <a:prstGeom prst="rect">
             <a:avLst/>
@@ -2902,56 +2661,14 @@
       </p:pic>
       <p:sp>
         <p:nvSpPr>
-          <p:cNvPr id="11" name="tag-mini"/>
-          <p:cNvSpPr/>
-          <p:nvPr/>
-        </p:nvSpPr>
-        <p:spPr>
-          <a:xfrm>
-            <a:off x="4681728" y="2103120"/>
-            <a:ext cx="832104" cy="292608"/>
-          </a:xfrm>
-          <a:prstGeom prst="roundRect">
-            <a:avLst>
-              <a:gd name="adj" fmla="val 50000"/>
-            </a:avLst>
-          </a:prstGeom>
-          <a:solidFill>
-            <a:schemeClr val="bg2"/>
-          </a:solidFill>
-          <a:ln/>
-        </p:spPr>
-      </p:sp>
-      <p:sp>
-        <p:nvSpPr>
-          <p:cNvPr id="12" name="Shape 9"/>
-          <p:cNvSpPr/>
-          <p:nvPr/>
-        </p:nvSpPr>
-        <p:spPr>
-          <a:xfrm>
-            <a:off x="4773168" y="2185416"/>
-            <a:ext cx="128016" cy="128016"/>
-          </a:xfrm>
-          <a:prstGeom prst="ellipse">
-            <a:avLst/>
-          </a:prstGeom>
-          <a:solidFill>
-            <a:schemeClr val="accent3"/>
-          </a:solidFill>
-          <a:ln/>
-        </p:spPr>
-      </p:sp>
-      <p:sp>
-        <p:nvSpPr>
-          <p:cNvPr id="13" name="Text 10"/>
+          <p:cNvPr id="3" name="Text 0"/>
           <p:cNvSpPr txBox="1"/>
           <p:nvPr/>
         </p:nvSpPr>
         <p:spPr>
           <a:xfrm>
-            <a:off x="4956048" y="2103120"/>
-            <a:ext cx="557784" cy="292608"/>
+            <a:off x="457200" y="2240280"/>
+            <a:ext cx="4023360" cy="548640"/>
           </a:xfrm>
           <a:prstGeom prst="rect">
             <a:avLst/>
@@ -2967,20 +2684,95 @@
               <a:buNone/>
             </a:pPr>
             <a:r>
-              <a:rPr lang="en-US" sz="1200" b="1" dirty="0">
-                <a:solidFill>
-                  <a:schemeClr val="tx1"/>
-                </a:solidFill>
-              </a:rPr>
-              <a:t>mini</a:t>
-            </a:r>
-            <a:endParaRPr lang="en-US" sz="1200" dirty="0"/>
+              <a:rPr lang="en-US" sz="2600" i="1" dirty="0">
+                <a:solidFill>
+                  <a:schemeClr val="bg2"/>
+                </a:solidFill>
+                <a:latin typeface="Cambria" pitchFamily="34" charset="0"/>
+                <a:ea typeface="Cambria" pitchFamily="34" charset="-122"/>
+                <a:cs typeface="Cambria" pitchFamily="34" charset="-120"/>
+              </a:rPr>
+              <a:t>one sip for every age</a:t>
+            </a:r>
+            <a:endParaRPr lang="en-US" sz="2600" dirty="0"/>
+          </a:p>
+        </p:txBody>
+      </p:sp>
+      <p:sp>
+        <p:nvSpPr>
+          <p:cNvPr id="4" name="Text 1"/>
+          <p:cNvSpPr txBox="1"/>
+          <p:nvPr/>
+        </p:nvSpPr>
+        <p:spPr>
+          <a:xfrm>
+            <a:off x="457200" y="2834640"/>
+            <a:ext cx="3840480" cy="594360"/>
+          </a:xfrm>
+          <a:prstGeom prst="rect">
+            <a:avLst/>
+          </a:prstGeom>
+          <a:noFill/>
+          <a:ln/>
+        </p:spPr>
+        <p:txBody>
+          <a:bodyPr wrap="square" lIns="0" tIns="0" rIns="0" bIns="0" rtlCol="0" anchor="ctr"/>
+          <a:lstStyle/>
+          <a:p>
+            <a:pPr indent="0" marL="0">
+              <a:buNone/>
+            </a:pPr>
+            <a:r>
+              <a:rPr lang="en-US" sz="1400" dirty="0">
+                <a:solidFill>
+                  <a:srgbClr val="D6CFC6"/>
+                </a:solidFill>
+              </a:rPr>
+              <a:t>The active straw: food supplements you drink, in 4 ranges, for ages 4 to 104.</a:t>
+            </a:r>
+            <a:endParaRPr lang="en-US" sz="1400" dirty="0"/>
+          </a:p>
+        </p:txBody>
+      </p:sp>
+      <p:sp>
+        <p:nvSpPr>
+          <p:cNvPr id="5" name="Text 2"/>
+          <p:cNvSpPr txBox="1"/>
+          <p:nvPr/>
+        </p:nvSpPr>
+        <p:spPr>
+          <a:xfrm>
+            <a:off x="457200" y="4343400"/>
+            <a:ext cx="4023360" cy="274320"/>
+          </a:xfrm>
+          <a:prstGeom prst="rect">
+            <a:avLst/>
+          </a:prstGeom>
+          <a:noFill/>
+          <a:ln/>
+        </p:spPr>
+        <p:txBody>
+          <a:bodyPr wrap="square" lIns="0" tIns="0" rIns="0" bIns="0" rtlCol="0" anchor="ctr"/>
+          <a:lstStyle/>
+          <a:p>
+            <a:pPr indent="0" marL="0">
+              <a:buNone/>
+            </a:pPr>
+            <a:r>
+              <a:rPr lang="en-US" sz="1100" dirty="0">
+                <a:solidFill>
+                  <a:srgbClr val="A99F96"/>
+                </a:solidFill>
+              </a:rPr>
+              <a:t>Nisrine Margoum · founder · investor pitch</a:t>
+            </a:r>
+            <a:endParaRPr lang="en-US" sz="1100" dirty="0"/>
           </a:p>
         </p:txBody>
       </p:sp>
       <p:pic>
         <p:nvPicPr>
-          <p:cNvPr id="14" name="cover-active" descr="cover-active">    </p:cNvPr>
+          <p:cNvPr id="6" name="cover-mini" descr="cover-mini">    </p:cNvPr>
           <p:cNvPicPr>
             <a:picLocks noChangeAspect="1"/>
           </p:cNvPicPr>
@@ -2994,7 +2786,7 @@
         </p:blipFill>
         <p:spPr>
           <a:xfrm>
-            <a:off x="6675120" y="457200"/>
+            <a:off x="4572000" y="457200"/>
             <a:ext cx="2011680" cy="2057400"/>
           </a:xfrm>
           <a:prstGeom prst="rect">
@@ -3004,14 +2796,14 @@
       </p:pic>
       <p:sp>
         <p:nvSpPr>
-          <p:cNvPr id="15" name="tag-active"/>
+          <p:cNvPr id="7" name="tag-mini"/>
           <p:cNvSpPr/>
           <p:nvPr/>
         </p:nvSpPr>
         <p:spPr>
           <a:xfrm>
-            <a:off x="6784848" y="2103120"/>
-            <a:ext cx="996696" cy="292608"/>
+            <a:off x="4681728" y="2103120"/>
+            <a:ext cx="832104" cy="292608"/>
           </a:xfrm>
           <a:prstGeom prst="roundRect">
             <a:avLst>
@@ -3026,34 +2818,34 @@
       </p:sp>
       <p:sp>
         <p:nvSpPr>
-          <p:cNvPr id="16" name="Shape 12"/>
+          <p:cNvPr id="8" name="Shape 4"/>
           <p:cNvSpPr/>
           <p:nvPr/>
         </p:nvSpPr>
         <p:spPr>
           <a:xfrm>
-            <a:off x="6876288" y="2185416"/>
+            <a:off x="4773168" y="2185416"/>
             <a:ext cx="128016" cy="128016"/>
           </a:xfrm>
           <a:prstGeom prst="ellipse">
             <a:avLst/>
           </a:prstGeom>
           <a:solidFill>
-            <a:schemeClr val="accent4"/>
+            <a:schemeClr val="accent3"/>
           </a:solidFill>
           <a:ln/>
         </p:spPr>
       </p:sp>
       <p:sp>
         <p:nvSpPr>
-          <p:cNvPr id="17" name="Text 13"/>
+          <p:cNvPr id="9" name="Text 5"/>
           <p:cNvSpPr txBox="1"/>
           <p:nvPr/>
         </p:nvSpPr>
         <p:spPr>
           <a:xfrm>
-            <a:off x="7059168" y="2103120"/>
-            <a:ext cx="722376" cy="292608"/>
+            <a:off x="4956048" y="2103120"/>
+            <a:ext cx="557784" cy="292608"/>
           </a:xfrm>
           <a:prstGeom prst="rect">
             <a:avLst/>
@@ -3074,7 +2866,7 @@
                   <a:schemeClr val="tx1"/>
                 </a:solidFill>
               </a:rPr>
-              <a:t>active</a:t>
+              <a:t>mini</a:t>
             </a:r>
             <a:endParaRPr lang="en-US" sz="1200" dirty="0"/>
           </a:p>
@@ -3082,7 +2874,7 @@
       </p:sp>
       <p:pic>
         <p:nvPicPr>
-          <p:cNvPr id="18" name="cover-luna" descr="cover-luna">    </p:cNvPr>
+          <p:cNvPr id="10" name="cover-active" descr="cover-active">    </p:cNvPr>
           <p:cNvPicPr>
             <a:picLocks noChangeAspect="1"/>
           </p:cNvPicPr>
@@ -3096,7 +2888,7 @@
         </p:blipFill>
         <p:spPr>
           <a:xfrm>
-            <a:off x="4572000" y="2606040"/>
+            <a:off x="6675120" y="457200"/>
             <a:ext cx="2011680" cy="2057400"/>
           </a:xfrm>
           <a:prstGeom prst="rect">
@@ -3106,14 +2898,14 @@
       </p:pic>
       <p:sp>
         <p:nvSpPr>
-          <p:cNvPr id="19" name="tag-luna"/>
+          <p:cNvPr id="11" name="tag-active"/>
           <p:cNvSpPr/>
           <p:nvPr/>
         </p:nvSpPr>
         <p:spPr>
           <a:xfrm>
-            <a:off x="4681728" y="4251960"/>
-            <a:ext cx="832104" cy="292608"/>
+            <a:off x="6784848" y="2103120"/>
+            <a:ext cx="996696" cy="292608"/>
           </a:xfrm>
           <a:prstGeom prst="roundRect">
             <a:avLst>
@@ -3128,34 +2920,34 @@
       </p:sp>
       <p:sp>
         <p:nvSpPr>
-          <p:cNvPr id="20" name="Shape 15"/>
+          <p:cNvPr id="12" name="Shape 7"/>
           <p:cNvSpPr/>
           <p:nvPr/>
         </p:nvSpPr>
         <p:spPr>
           <a:xfrm>
-            <a:off x="4773168" y="4334256"/>
+            <a:off x="6876288" y="2185416"/>
             <a:ext cx="128016" cy="128016"/>
           </a:xfrm>
           <a:prstGeom prst="ellipse">
             <a:avLst/>
           </a:prstGeom>
           <a:solidFill>
-            <a:schemeClr val="accent1"/>
+            <a:schemeClr val="accent4"/>
           </a:solidFill>
           <a:ln/>
         </p:spPr>
       </p:sp>
       <p:sp>
         <p:nvSpPr>
-          <p:cNvPr id="21" name="Text 16"/>
+          <p:cNvPr id="13" name="Text 8"/>
           <p:cNvSpPr txBox="1"/>
           <p:nvPr/>
         </p:nvSpPr>
         <p:spPr>
           <a:xfrm>
-            <a:off x="4956048" y="4251960"/>
-            <a:ext cx="557784" cy="292608"/>
+            <a:off x="7059168" y="2103120"/>
+            <a:ext cx="722376" cy="292608"/>
           </a:xfrm>
           <a:prstGeom prst="rect">
             <a:avLst/>
@@ -3176,7 +2968,7 @@
                   <a:schemeClr val="tx1"/>
                 </a:solidFill>
               </a:rPr>
-              <a:t>luna</a:t>
+              <a:t>active</a:t>
             </a:r>
             <a:endParaRPr lang="en-US" sz="1200" dirty="0"/>
           </a:p>
@@ -3184,7 +2976,7 @@
       </p:sp>
       <p:pic>
         <p:nvPicPr>
-          <p:cNvPr id="22" name="cover-silver" descr="cover-silver">    </p:cNvPr>
+          <p:cNvPr id="14" name="cover-luna" descr="cover-luna">    </p:cNvPr>
           <p:cNvPicPr>
             <a:picLocks noChangeAspect="1"/>
           </p:cNvPicPr>
@@ -3198,7 +2990,7 @@
         </p:blipFill>
         <p:spPr>
           <a:xfrm>
-            <a:off x="6675120" y="2606040"/>
+            <a:off x="4572000" y="2606040"/>
             <a:ext cx="2011680" cy="2057400"/>
           </a:xfrm>
           <a:prstGeom prst="rect">
@@ -3208,14 +3000,14 @@
       </p:pic>
       <p:sp>
         <p:nvSpPr>
-          <p:cNvPr id="23" name="tag-silver"/>
+          <p:cNvPr id="15" name="tag-luna"/>
           <p:cNvSpPr/>
           <p:nvPr/>
         </p:nvSpPr>
         <p:spPr>
           <a:xfrm>
-            <a:off x="6784848" y="4251960"/>
-            <a:ext cx="996696" cy="292608"/>
+            <a:off x="4681728" y="4251960"/>
+            <a:ext cx="832104" cy="292608"/>
           </a:xfrm>
           <a:prstGeom prst="roundRect">
             <a:avLst>
@@ -3230,7 +3022,109 @@
       </p:sp>
       <p:sp>
         <p:nvSpPr>
-          <p:cNvPr id="24" name="Shape 18"/>
+          <p:cNvPr id="16" name="Shape 10"/>
+          <p:cNvSpPr/>
+          <p:nvPr/>
+        </p:nvSpPr>
+        <p:spPr>
+          <a:xfrm>
+            <a:off x="4773168" y="4334256"/>
+            <a:ext cx="128016" cy="128016"/>
+          </a:xfrm>
+          <a:prstGeom prst="ellipse">
+            <a:avLst/>
+          </a:prstGeom>
+          <a:solidFill>
+            <a:schemeClr val="accent1"/>
+          </a:solidFill>
+          <a:ln/>
+        </p:spPr>
+      </p:sp>
+      <p:sp>
+        <p:nvSpPr>
+          <p:cNvPr id="17" name="Text 11"/>
+          <p:cNvSpPr txBox="1"/>
+          <p:nvPr/>
+        </p:nvSpPr>
+        <p:spPr>
+          <a:xfrm>
+            <a:off x="4956048" y="4251960"/>
+            <a:ext cx="557784" cy="292608"/>
+          </a:xfrm>
+          <a:prstGeom prst="rect">
+            <a:avLst/>
+          </a:prstGeom>
+          <a:noFill/>
+          <a:ln/>
+        </p:spPr>
+        <p:txBody>
+          <a:bodyPr wrap="square" lIns="0" tIns="0" rIns="0" bIns="0" rtlCol="0" anchor="ctr"/>
+          <a:lstStyle/>
+          <a:p>
+            <a:pPr indent="0" marL="0">
+              <a:buNone/>
+            </a:pPr>
+            <a:r>
+              <a:rPr lang="en-US" sz="1200" b="1" dirty="0">
+                <a:solidFill>
+                  <a:schemeClr val="tx1"/>
+                </a:solidFill>
+              </a:rPr>
+              <a:t>luna</a:t>
+            </a:r>
+            <a:endParaRPr lang="en-US" sz="1200" dirty="0"/>
+          </a:p>
+        </p:txBody>
+      </p:sp>
+      <p:pic>
+        <p:nvPicPr>
+          <p:cNvPr id="18" name="cover-silver" descr="cover-silver">    </p:cNvPr>
+          <p:cNvPicPr>
+            <a:picLocks noChangeAspect="1"/>
+          </p:cNvPicPr>
+          <p:nvPr/>
+        </p:nvPicPr>
+        <p:blipFill>
+          <a:blip r:embed="rId5"/>
+          <a:stretch>
+            <a:fillRect/>
+          </a:stretch>
+        </p:blipFill>
+        <p:spPr>
+          <a:xfrm>
+            <a:off x="6675120" y="2606040"/>
+            <a:ext cx="2011680" cy="2057400"/>
+          </a:xfrm>
+          <a:prstGeom prst="rect">
+            <a:avLst/>
+          </a:prstGeom>
+        </p:spPr>
+      </p:pic>
+      <p:sp>
+        <p:nvSpPr>
+          <p:cNvPr id="19" name="tag-silver"/>
+          <p:cNvSpPr/>
+          <p:nvPr/>
+        </p:nvSpPr>
+        <p:spPr>
+          <a:xfrm>
+            <a:off x="6784848" y="4251960"/>
+            <a:ext cx="996696" cy="292608"/>
+          </a:xfrm>
+          <a:prstGeom prst="roundRect">
+            <a:avLst>
+              <a:gd name="adj" fmla="val 50000"/>
+            </a:avLst>
+          </a:prstGeom>
+          <a:solidFill>
+            <a:schemeClr val="bg2"/>
+          </a:solidFill>
+          <a:ln/>
+        </p:spPr>
+      </p:sp>
+      <p:sp>
+        <p:nvSpPr>
+          <p:cNvPr id="20" name="Shape 13"/>
           <p:cNvSpPr/>
           <p:nvPr/>
         </p:nvSpPr>
@@ -3250,7 +3144,7 @@
       </p:sp>
       <p:sp>
         <p:nvSpPr>
-          <p:cNvPr id="25" name="Text 19"/>
+          <p:cNvPr id="21" name="Text 14"/>
           <p:cNvSpPr txBox="1"/>
           <p:nvPr/>
         </p:nvSpPr>
@@ -5659,89 +5553,33 @@
           </a:prstGeom>
         </p:spPr>
       </p:pic>
-      <p:sp>
-        <p:nvSpPr>
-          <p:cNvPr id="3" name="bead0"/>
-          <p:cNvSpPr/>
-          <p:nvPr/>
-        </p:nvSpPr>
-        <p:spPr>
-          <a:xfrm>
-            <a:off x="502920" y="1051560"/>
-            <a:ext cx="164592" cy="164592"/>
-          </a:xfrm>
-          <a:prstGeom prst="ellipse">
-            <a:avLst/>
-          </a:prstGeom>
-          <a:solidFill>
-            <a:schemeClr val="accent3"/>
-          </a:solidFill>
-          <a:ln/>
-        </p:spPr>
-      </p:sp>
-      <p:sp>
-        <p:nvSpPr>
-          <p:cNvPr id="4" name="bead1"/>
-          <p:cNvSpPr/>
-          <p:nvPr/>
-        </p:nvSpPr>
-        <p:spPr>
-          <a:xfrm>
-            <a:off x="758952" y="1051560"/>
-            <a:ext cx="164592" cy="164592"/>
-          </a:xfrm>
-          <a:prstGeom prst="ellipse">
-            <a:avLst/>
-          </a:prstGeom>
-          <a:solidFill>
-            <a:schemeClr val="accent4"/>
-          </a:solidFill>
-          <a:ln/>
-        </p:spPr>
-      </p:sp>
-      <p:sp>
-        <p:nvSpPr>
-          <p:cNvPr id="5" name="bead2"/>
-          <p:cNvSpPr/>
-          <p:nvPr/>
-        </p:nvSpPr>
-        <p:spPr>
-          <a:xfrm>
-            <a:off x="1014984" y="1051560"/>
-            <a:ext cx="164592" cy="164592"/>
-          </a:xfrm>
-          <a:prstGeom prst="ellipse">
-            <a:avLst/>
-          </a:prstGeom>
-          <a:solidFill>
-            <a:schemeClr val="accent1"/>
-          </a:solidFill>
-          <a:ln/>
-        </p:spPr>
-      </p:sp>
-      <p:sp>
-        <p:nvSpPr>
-          <p:cNvPr id="6" name="bead3"/>
-          <p:cNvSpPr/>
-          <p:nvPr/>
-        </p:nvSpPr>
-        <p:spPr>
-          <a:xfrm>
-            <a:off x="1271016" y="1051560"/>
-            <a:ext cx="164592" cy="164592"/>
-          </a:xfrm>
-          <a:prstGeom prst="ellipse">
-            <a:avLst/>
-          </a:prstGeom>
-          <a:solidFill>
-            <a:schemeClr val="accent2"/>
-          </a:solidFill>
-          <a:ln/>
-        </p:spPr>
-      </p:sp>
-      <p:sp>
-        <p:nvSpPr>
-          <p:cNvPr id="7" name="Text 4"/>
+      <p:pic>
+        <p:nvPicPr>
+          <p:cNvPr id="3" name="logo-close" descr="sip lab logo">    </p:cNvPr>
+          <p:cNvPicPr>
+            <a:picLocks noChangeAspect="1"/>
+          </p:cNvPicPr>
+          <p:nvPr/>
+        </p:nvPicPr>
+        <p:blipFill>
+          <a:blip r:embed="rId2"/>
+          <a:stretch>
+            <a:fillRect/>
+          </a:stretch>
+        </p:blipFill>
+        <p:spPr>
+          <a:xfrm>
+            <a:off x="365760" y="411480"/>
+            <a:ext cx="1737360" cy="710335"/>
+          </a:xfrm>
+          <a:prstGeom prst="rect">
+            <a:avLst/>
+          </a:prstGeom>
+        </p:spPr>
+      </p:pic>
+      <p:sp>
+        <p:nvSpPr>
+          <p:cNvPr id="4" name="Text 0"/>
           <p:cNvSpPr txBox="1"/>
           <p:nvPr/>
         </p:nvSpPr>
@@ -5791,7 +5629,7 @@
       </p:sp>
       <p:sp>
         <p:nvSpPr>
-          <p:cNvPr id="8" name="Text 5"/>
+          <p:cNvPr id="5" name="Text 1"/>
           <p:cNvSpPr txBox="1"/>
           <p:nvPr/>
         </p:nvSpPr>
@@ -5827,7 +5665,7 @@
       </p:sp>
       <p:sp>
         <p:nvSpPr>
-          <p:cNvPr id="9" name="Text 6"/>
+          <p:cNvPr id="6" name="Text 2"/>
           <p:cNvSpPr txBox="1"/>
           <p:nvPr/>
         </p:nvSpPr>

</xml_diff>

<commit_message>
Logo : symbole paille coudée (billes des 4 gammes conservées), appliqué au site, pitch et livrable
Co-Authored-By: Claude Opus 5.5 <noreply@anthropic.com>
Claude-Session: https://claude.ai/code/session_01GhVoXRgaJJbfXgbund27Nd
</commit_message>
<xml_diff>
--- a/pitch/siplab-pitch-EN.pptx
+++ b/pitch/siplab-pitch-EN.pptx
@@ -120,44 +120,44 @@
   <p:extLst>
     <p:ext uri="{521415D9-36F7-43E2-AB2F-B90AF26B5E84}">
       <p14:sectionLst xmlns:p14="http://schemas.microsoft.com/office/powerpoint/2010/main">
-        <p14:section name="Opening" id="{d6dca191-bcea-e8d5-e2aa-e477a1ebe178}">
+        <p14:section name="Opening" id="{de75b258-c190-9931-b552-d97f69564262}">
           <p14:sldIdLst>
             <p14:sldId id="256"/>
           </p14:sldIdLst>
         </p14:section>
-        <p14:section name="Problem &amp; solution" id="{98c1f50b-279e-5a7e-bd5d-ebf3765d183e}">
+        <p14:section name="Problem &amp; solution" id="{e8aa688c-82e6-bbba-e494-e686d29ded77}">
           <p14:sldIdLst>
             <p14:sldId id="257"/>
             <p14:sldId id="258"/>
             <p14:sldId id="259"/>
           </p14:sldIdLst>
         </p14:section>
-        <p14:section name="Market" id="{da4da198-a4ae-a42e-2d16-a6f2330352bb}">
+        <p14:section name="Market" id="{0f913486-9312-f034-0716-1fe0c13cd337}">
           <p14:sldIdLst>
             <p14:sldId id="260"/>
             <p14:sldId id="261"/>
             <p14:sldId id="262"/>
           </p14:sldIdLst>
         </p14:section>
-        <p14:section name="Model &amp; growth" id="{4df42e5c-c7c6-b180-cbf6-0c4287562810}">
+        <p14:section name="Model &amp; growth" id="{14efc6d9-799c-9bb7-82de-f4bd7c9ffb07}">
           <p14:sldIdLst>
             <p14:sldId id="263"/>
             <p14:sldId id="264"/>
             <p14:sldId id="265"/>
           </p14:sldIdLst>
         </p14:section>
-        <p14:section name="Team &amp; funding" id="{da50fecc-9ffd-588e-5987-98491661f24f}">
+        <p14:section name="Team &amp; funding" id="{221d667c-257b-458f-ca8d-21af11ffcf7f}">
           <p14:sldIdLst>
             <p14:sldId id="266"/>
             <p14:sldId id="267"/>
           </p14:sldIdLst>
         </p14:section>
-        <p14:section name="Conclusion" id="{bef48d92-248b-603f-fe64-cd3aac725c4f}">
+        <p14:section name="Conclusion" id="{d76be8ce-8ae7-a4f3-e04b-92489314e881}">
           <p14:sldIdLst>
             <p14:sldId id="268"/>
           </p14:sldIdLst>
         </p14:section>
-        <p14:section name="Appendix" id="{f75eda93-c307-b5ec-631e-57c87081f478}">
+        <p14:section name="Appendix" id="{eb8d910a-af29-372f-c88a-365fa8c76fa7}">
           <p14:sldIdLst>
             <p14:sldId id="269"/>
           </p14:sldIdLst>

</xml_diff>

<commit_message>
Pitch EN : couverture sur fond clair avec le logo foncé
Co-Authored-By: Claude Opus 5.5 <noreply@anthropic.com>
Claude-Session: https://claude.ai/code/session_01GhVoXRgaJJbfXgbund27Nd
</commit_message>
<xml_diff>
--- a/pitch/siplab-pitch-EN.pptx
+++ b/pitch/siplab-pitch-EN.pptx
@@ -120,44 +120,44 @@
   <p:extLst>
     <p:ext uri="{521415D9-36F7-43E2-AB2F-B90AF26B5E84}">
       <p14:sectionLst xmlns:p14="http://schemas.microsoft.com/office/powerpoint/2010/main">
-        <p14:section name="Opening" id="{de75b258-c190-9931-b552-d97f69564262}">
+        <p14:section name="Opening" id="{f48fe81c-2e43-a001-59c9-23be5b51d28c}">
           <p14:sldIdLst>
             <p14:sldId id="256"/>
           </p14:sldIdLst>
         </p14:section>
-        <p14:section name="Problem &amp; solution" id="{e8aa688c-82e6-bbba-e494-e686d29ded77}">
+        <p14:section name="Problem &amp; solution" id="{7bc8720a-4ba3-9b3e-29b7-036733a99c0f}">
           <p14:sldIdLst>
             <p14:sldId id="257"/>
             <p14:sldId id="258"/>
             <p14:sldId id="259"/>
           </p14:sldIdLst>
         </p14:section>
-        <p14:section name="Market" id="{0f913486-9312-f034-0716-1fe0c13cd337}">
+        <p14:section name="Market" id="{18d40206-ed78-9556-56d7-dfbf851c74b5}">
           <p14:sldIdLst>
             <p14:sldId id="260"/>
             <p14:sldId id="261"/>
             <p14:sldId id="262"/>
           </p14:sldIdLst>
         </p14:section>
-        <p14:section name="Model &amp; growth" id="{14efc6d9-799c-9bb7-82de-f4bd7c9ffb07}">
+        <p14:section name="Model &amp; growth" id="{939f39c9-577d-3adb-ea1e-32256b6fa02e}">
           <p14:sldIdLst>
             <p14:sldId id="263"/>
             <p14:sldId id="264"/>
             <p14:sldId id="265"/>
           </p14:sldIdLst>
         </p14:section>
-        <p14:section name="Team &amp; funding" id="{221d667c-257b-458f-ca8d-21af11ffcf7f}">
+        <p14:section name="Team &amp; funding" id="{c904866b-eb5b-817f-6f9f-556d60fe2a57}">
           <p14:sldIdLst>
             <p14:sldId id="266"/>
             <p14:sldId id="267"/>
           </p14:sldIdLst>
         </p14:section>
-        <p14:section name="Conclusion" id="{d76be8ce-8ae7-a4f3-e04b-92489314e881}">
+        <p14:section name="Conclusion" id="{48b27d5f-66b7-26d4-581b-8934e4389135}">
           <p14:sldIdLst>
             <p14:sldId id="268"/>
           </p14:sldIdLst>
         </p14:section>
-        <p14:section name="Appendix" id="{eb8d910a-af29-372f-c88a-365fa8c76fa7}">
+        <p14:section name="Appendix" id="{21f3bba6-7ac5-0ebd-8b34-75523d8ecd8a}">
           <p14:sldIdLst>
             <p14:sldId id="269"/>
           </p14:sldIdLst>
@@ -2105,6 +2105,38 @@
 
 <file path=ppt/slideLayouts/slideLayout3.xml><?xml version="1.0" encoding="utf-8"?>
 <p:sldLayout xmlns:a="http://schemas.openxmlformats.org/drawingml/2006/main" xmlns:r="http://schemas.openxmlformats.org/officeDocument/2006/relationships" xmlns:p="http://schemas.openxmlformats.org/presentationml/2006/main" preserve="1">
+  <p:cSld name="LIGHT">
+    <p:bg>
+      <p:bgPr>
+        <a:solidFill>
+          <a:schemeClr val="bg2"/>
+        </a:solidFill>
+      </p:bgPr>
+    </p:bg>
+    <p:spTree>
+      <p:nvGrpSpPr>
+        <p:cNvPr id="1" name=""/>
+        <p:cNvGrpSpPr/>
+        <p:nvPr/>
+      </p:nvGrpSpPr>
+      <p:grpSpPr>
+        <a:xfrm>
+          <a:off x="0" y="0"/>
+          <a:ext cx="0" cy="0"/>
+          <a:chOff x="0" y="0"/>
+          <a:chExt cx="0" cy="0"/>
+        </a:xfrm>
+      </p:grpSpPr>
+    </p:spTree>
+  </p:cSld>
+  <p:clrMapOvr>
+    <a:masterClrMapping/>
+  </p:clrMapOvr>
+</p:sldLayout>
+</file>
+
+<file path=ppt/slideLayouts/slideLayout4.xml><?xml version="1.0" encoding="utf-8"?>
+<p:sldLayout xmlns:a="http://schemas.openxmlformats.org/drawingml/2006/main" xmlns:r="http://schemas.openxmlformats.org/officeDocument/2006/relationships" xmlns:p="http://schemas.openxmlformats.org/presentationml/2006/main" preserve="1">
   <p:cSld name="CONTENT">
     <p:bg>
       <p:bgPr>
@@ -2280,7 +2312,7 @@
             <a:pPr algn="r"/>
             <a:fld id="{F7021451-1387-4CA6-816F-3879F97B5CBC}" type="slidenum">
               <a:rPr b="0" lang="en-US"/>
-              <a:t>1003</a:t>
+              <a:t>1004</a:t>
             </a:fld>
             <a:endParaRPr lang="en-US"/>
           </a:p>
@@ -2363,6 +2395,7 @@
     <p:sldLayoutId id="2147483649" r:id="rId1"/>
     <p:sldLayoutId id="2147483650" r:id="rId2"/>
     <p:sldLayoutId id="2147483651" r:id="rId3"/>
+    <p:sldLayoutId id="2147483652" r:id="rId4"/>
   </p:sldLayoutIdLst>
   <p:hf sldNum="0" hdr="0" ftr="0" dt="0"/>
   <p:txStyles>
@@ -2686,7 +2719,7 @@
             <a:r>
               <a:rPr lang="en-US" sz="2600" i="1" dirty="0">
                 <a:solidFill>
-                  <a:schemeClr val="bg2"/>
+                  <a:schemeClr val="accent1"/>
                 </a:solidFill>
                 <a:latin typeface="Cambria" pitchFamily="34" charset="0"/>
                 <a:ea typeface="Cambria" pitchFamily="34" charset="-122"/>
@@ -2725,7 +2758,7 @@
             <a:r>
               <a:rPr lang="en-US" sz="1400" dirty="0">
                 <a:solidFill>
-                  <a:srgbClr val="D6CFC6"/>
+                  <a:schemeClr val="tx1"/>
                 </a:solidFill>
               </a:rPr>
               <a:t>The active straw: food supplements you drink, in 4 ranges, for ages 4 to 104.</a:t>
@@ -2761,7 +2794,7 @@
             <a:r>
               <a:rPr lang="en-US" sz="1100" dirty="0">
                 <a:solidFill>
-                  <a:srgbClr val="A99F96"/>
+                  <a:schemeClr val="tx2"/>
                 </a:solidFill>
               </a:rPr>
               <a:t>Nisrine Margoum · founder · investor pitch</a:t>
@@ -2811,7 +2844,7 @@
             </a:avLst>
           </a:prstGeom>
           <a:solidFill>
-            <a:schemeClr val="bg2"/>
+            <a:srgbClr val="FFFFFF"/>
           </a:solidFill>
           <a:ln/>
         </p:spPr>
@@ -2913,7 +2946,7 @@
             </a:avLst>
           </a:prstGeom>
           <a:solidFill>
-            <a:schemeClr val="bg2"/>
+            <a:srgbClr val="FFFFFF"/>
           </a:solidFill>
           <a:ln/>
         </p:spPr>
@@ -3015,7 +3048,7 @@
             </a:avLst>
           </a:prstGeom>
           <a:solidFill>
-            <a:schemeClr val="bg2"/>
+            <a:srgbClr val="FFFFFF"/>
           </a:solidFill>
           <a:ln/>
         </p:spPr>
@@ -3117,7 +3150,7 @@
             </a:avLst>
           </a:prstGeom>
           <a:solidFill>
-            <a:schemeClr val="bg2"/>
+            <a:srgbClr val="FFFFFF"/>
           </a:solidFill>
           <a:ln/>
         </p:spPr>

</xml_diff>

<commit_message>
Pitch EN : retour de la couverture sur fond noir (logo paille blanc)
Co-Authored-By: Claude Opus 5.5 <noreply@anthropic.com>
Claude-Session: https://claude.ai/code/session_01GhVoXRgaJJbfXgbund27Nd
</commit_message>
<xml_diff>
--- a/pitch/siplab-pitch-EN.pptx
+++ b/pitch/siplab-pitch-EN.pptx
@@ -120,44 +120,44 @@
   <p:extLst>
     <p:ext uri="{521415D9-36F7-43E2-AB2F-B90AF26B5E84}">
       <p14:sectionLst xmlns:p14="http://schemas.microsoft.com/office/powerpoint/2010/main">
-        <p14:section name="Opening" id="{f48fe81c-2e43-a001-59c9-23be5b51d28c}">
+        <p14:section name="Opening" id="{3e6b467d-34ed-23d8-3287-294586c354e6}">
           <p14:sldIdLst>
             <p14:sldId id="256"/>
           </p14:sldIdLst>
         </p14:section>
-        <p14:section name="Problem &amp; solution" id="{7bc8720a-4ba3-9b3e-29b7-036733a99c0f}">
+        <p14:section name="Problem &amp; solution" id="{4eba92d7-cc04-8a1f-53ae-38a97eeb2116}">
           <p14:sldIdLst>
             <p14:sldId id="257"/>
             <p14:sldId id="258"/>
             <p14:sldId id="259"/>
           </p14:sldIdLst>
         </p14:section>
-        <p14:section name="Market" id="{18d40206-ed78-9556-56d7-dfbf851c74b5}">
+        <p14:section name="Market" id="{556e7c5b-a55d-e903-e6d5-86e47c022f3b}">
           <p14:sldIdLst>
             <p14:sldId id="260"/>
             <p14:sldId id="261"/>
             <p14:sldId id="262"/>
           </p14:sldIdLst>
         </p14:section>
-        <p14:section name="Model &amp; growth" id="{939f39c9-577d-3adb-ea1e-32256b6fa02e}">
+        <p14:section name="Model &amp; growth" id="{8e89f1ac-0522-9e97-a0d2-5c55640fa0b0}">
           <p14:sldIdLst>
             <p14:sldId id="263"/>
             <p14:sldId id="264"/>
             <p14:sldId id="265"/>
           </p14:sldIdLst>
         </p14:section>
-        <p14:section name="Team &amp; funding" id="{c904866b-eb5b-817f-6f9f-556d60fe2a57}">
+        <p14:section name="Team &amp; funding" id="{55909d50-6eb5-209a-876e-ded787eef8bb}">
           <p14:sldIdLst>
             <p14:sldId id="266"/>
             <p14:sldId id="267"/>
           </p14:sldIdLst>
         </p14:section>
-        <p14:section name="Conclusion" id="{48b27d5f-66b7-26d4-581b-8934e4389135}">
+        <p14:section name="Conclusion" id="{5b167c5c-6817-54d1-89d2-e24c9f82665c}">
           <p14:sldIdLst>
             <p14:sldId id="268"/>
           </p14:sldIdLst>
         </p14:section>
-        <p14:section name="Appendix" id="{21f3bba6-7ac5-0ebd-8b34-75523d8ecd8a}">
+        <p14:section name="Appendix" id="{75c0db63-64ec-f8c1-ff81-120c2507ceca}">
           <p14:sldIdLst>
             <p14:sldId id="269"/>
           </p14:sldIdLst>
@@ -2719,7 +2719,7 @@
             <a:r>
               <a:rPr lang="en-US" sz="2600" i="1" dirty="0">
                 <a:solidFill>
-                  <a:schemeClr val="accent1"/>
+                  <a:schemeClr val="bg2"/>
                 </a:solidFill>
                 <a:latin typeface="Cambria" pitchFamily="34" charset="0"/>
                 <a:ea typeface="Cambria" pitchFamily="34" charset="-122"/>
@@ -2758,7 +2758,7 @@
             <a:r>
               <a:rPr lang="en-US" sz="1400" dirty="0">
                 <a:solidFill>
-                  <a:schemeClr val="tx1"/>
+                  <a:srgbClr val="D6CFC6"/>
                 </a:solidFill>
               </a:rPr>
               <a:t>The active straw: food supplements you drink, in 4 ranges, for ages 4 to 104.</a:t>
@@ -2794,7 +2794,7 @@
             <a:r>
               <a:rPr lang="en-US" sz="1100" dirty="0">
                 <a:solidFill>
-                  <a:schemeClr val="tx2"/>
+                  <a:srgbClr val="A99F96"/>
                 </a:solidFill>
               </a:rPr>
               <a:t>Nisrine Margoum · founder · investor pitch</a:t>
@@ -2844,7 +2844,7 @@
             </a:avLst>
           </a:prstGeom>
           <a:solidFill>
-            <a:srgbClr val="FFFFFF"/>
+            <a:schemeClr val="bg2"/>
           </a:solidFill>
           <a:ln/>
         </p:spPr>
@@ -2946,7 +2946,7 @@
             </a:avLst>
           </a:prstGeom>
           <a:solidFill>
-            <a:srgbClr val="FFFFFF"/>
+            <a:schemeClr val="bg2"/>
           </a:solidFill>
           <a:ln/>
         </p:spPr>
@@ -3048,7 +3048,7 @@
             </a:avLst>
           </a:prstGeom>
           <a:solidFill>
-            <a:srgbClr val="FFFFFF"/>
+            <a:schemeClr val="bg2"/>
           </a:solidFill>
           <a:ln/>
         </p:spPr>
@@ -3150,7 +3150,7 @@
             </a:avLst>
           </a:prstGeom>
           <a:solidFill>
-            <a:srgbClr val="FFFFFF"/>
+            <a:schemeClr val="bg2"/>
           </a:solidFill>
           <a:ln/>
         </p:spPr>

</xml_diff>